<commit_message>
Put the teams and the platform after One platform and count Data and Voice calls in the presentations
Built for every team and Enterprise-ready follow One platform in the
Overview deck, and the CDR figure counts the calls of the Data and
Voice CDRs (a Speech CDR measures calls of the Voice one), shown as
calls; the number of CDRs is unchanged.

Co-Authored-By: Claude Opus 5.5 <noreply@anthropic.com>
</commit_message>
<xml_diff>
--- a/src/web_interface/static/presentations/one-slider.pptx
+++ b/src/web_interface/static/presentations/one-slider.pptx
@@ -107,7 +107,7 @@
   <p:extLst>
     <p:ext uri="{521415D9-36F7-43E2-AB2F-B90AF26B5E84}">
       <p14:sectionLst xmlns:p14="http://schemas.microsoft.com/office/powerpoint/2010/main">
-        <p14:section name="DriveTest Analyzer" id="{413d5c7f-a6a7-fad2-91f5-2d59df341f07}">
+        <p14:section name="DriveTest Analyzer" id="{f3895372-e3d6-12ba-a808-429032789f22}">
           <p14:sldIdLst>
             <p14:sldId id="256"/>
           </p14:sldIdLst>
@@ -516,7 +516,7 @@
           <a:p>
             <a:r>
               <a:rPr lang="en-US" dirty="0"/>
-              <a:t>DriveTest Analyzer in one slide. Data in: CDRs (7.5 M rows in 27 CDRs of 9 campaigns of the UK workspace), network inventories, vendor mappings and regions and clusters. On one shared workspace, eight modules: CDR Analysis, PPT Dashboards, Scoring &amp; GAP Analysis, Network Insights, Non-Qualified Calls (48,138 NQ calls), Reporting, the Builders and the Ticket Center. They serve benchmarking, the NQ team, troubleshooting and technical and executive reporting, on an enterprise platform on AWS with roles, isolated workspaces, automated backups, a Ticket Center, a 25-chapter Help and 1,895 automated tests. Roadmap: Umlaut CDRs and the Active Tests community next, then scale-out on AWS and speed, then PostgreSQL for hundreds of concurrent users and health monitoring.</a:t>
+              <a:t>DriveTest Analyzer in one slide. Data in: CDRs (3.8 M Data and Voice calls in 27 CDRs of 9 campaigns of the UK workspace), network inventories, vendor mappings and regions and clusters. On one shared workspace, eight modules: CDR Analysis, PPT Dashboards, Scoring &amp; GAP Analysis, Network Insights, Non-Qualified Calls (48,138 NQ calls), Reporting, the Builders and the Ticket Center. They serve benchmarking, the NQ team, troubleshooting and technical and executive reporting, on an enterprise platform on AWS with roles, isolated workspaces, automated backups, a Ticket Center, a 25-chapter Help and 1,895 automated tests. Roadmap: Umlaut CDRs and the Active Tests community next, then scale-out on AWS and speed, then PostgreSQL for hundreds of concurrent users and health monitoring.</a:t>
             </a:r>
             <a:endParaRPr lang="en-US" dirty="0"/>
           </a:p>
@@ -646,7 +646,7 @@
       </p:grpSpPr>
       <p:pic>
         <p:nvPicPr>
-          <p:cNvPr id="2" name="Image 0" descr="/var/folders/pl/_b6qn8zs2_lc59t589_46cyc0000gn/T/drivetest-presentations-rNxAPW/ericsson-logo-black.png">    </p:cNvPr>
+          <p:cNvPr id="2" name="Image 0" descr="/var/folders/pl/_b6qn8zs2_lc59t589_46cyc0000gn/T/drivetest-presentations-0nCbo0/ericsson-logo-black.png">    </p:cNvPr>
           <p:cNvPicPr>
             <a:picLocks noChangeAspect="1"/>
           </p:cNvPicPr>
@@ -831,7 +831,7 @@
       </p:grpSpPr>
       <p:pic>
         <p:nvPicPr>
-          <p:cNvPr id="2" name="Image 0" descr="/var/folders/pl/_b6qn8zs2_lc59t589_46cyc0000gn/T/drivetest-presentations-rNxAPW/ericsson-logo-black.png">    </p:cNvPr>
+          <p:cNvPr id="2" name="Image 0" descr="/var/folders/pl/_b6qn8zs2_lc59t589_46cyc0000gn/T/drivetest-presentations-0nCbo0/ericsson-logo-black.png">    </p:cNvPr>
           <p:cNvPicPr>
             <a:picLocks noChangeAspect="1"/>
           </p:cNvPicPr>
@@ -1289,7 +1289,7 @@
       </p:grpSpPr>
       <p:pic>
         <p:nvPicPr>
-          <p:cNvPr id="2" name="Small roadmap road" descr="/var/folders/pl/_b6qn8zs2_lc59t589_46cyc0000gn/T/drivetest-presentations-rNxAPW/mini-road.png">    </p:cNvPr>
+          <p:cNvPr id="2" name="Small roadmap road" descr="/var/folders/pl/_b6qn8zs2_lc59t589_46cyc0000gn/T/drivetest-presentations-0nCbo0/mini-road.png">    </p:cNvPr>
           <p:cNvPicPr>
             <a:picLocks noChangeAspect="1"/>
           </p:cNvPicPr>
@@ -1655,7 +1655,7 @@
                 <a:ea typeface="Arial" pitchFamily="34" charset="-122"/>
                 <a:cs typeface="Arial" pitchFamily="34" charset="-120"/>
               </a:rPr>
-              <a:t>7.5 M </a:t>
+              <a:t>3.8 M </a:t>
             </a:r>
             <a:pPr indent="0" marL="0">
               <a:buNone/>
@@ -1669,7 +1669,7 @@
                 <a:ea typeface="Arial" pitchFamily="34" charset="-122"/>
                 <a:cs typeface="Arial" pitchFamily="34" charset="-120"/>
               </a:rPr>
-              <a:t>rows · 27 CDRs</a:t>
+              <a:t>calls · 27 CDRs</a:t>
             </a:r>
             <a:endParaRPr lang="en-US" sz="1400" dirty="0"/>
           </a:p>

</xml_diff>